<commit_message>
cai_tien (VN): sửa sai "MedRegA box gộp thô" + framing IoU cho đúng
Subagent kiểm paper (Algorithm 1 + Figure 8):
- MedRegA CŨNG multi-box (không gộp 1 box) → bỏ claim sai "box gộp thô";
  đổi thành "box lỏng (không cần khít)" vs "box khít từng ổ".
- IoU 0.23 của họ là MATCHED-only (không phạt miss) trên đích lớn+box lỏng
  → dòng so sửa thành "cùng chuẩn matched ~0.32 vs 0.23; pIoU 0.27 có phạt
  khắt khe hơn". Thêm defense vào speaker notes.
Chỉ sửa bản VN (5min VN + full VN + slides_mach_paper); EN để sau.

Co-Authored-By: Claude Opus 4.8 <noreply@anthropic.com>
</commit_message>
<xml_diff>
--- a/seminar/cai_tien/slides_5min_VN.pptx
+++ b/seminar/cai_tien/slides_5min_VN.pptx
@@ -546,7 +546,7 @@
           </a:p>
           <a:p>
             <a:r>
-              <a:t>• ~0.27 vs MedRegA ~0.23 = cùng khoảng dù nhỏ 5×, KHÁC dataset nên chỉ tham khảo, KHÔNG claim hơn.</a:t>
+              <a:t>• vs MedRegA (Q&amp;A): IoU 0.23 của họ tính MATCHED-ONLY (không phạt miss — Algorithm 1 Hungarian) + đích chủ yếu CẤU TRÚC LỚN + box LỎNG ("không cần khít", paper). Cùng chuẩn matched: mình ~0.32 &gt; 0.23. pIoU 0.27 của mình CÓ PHẠT nên khắt khe hơn. KHÔNG nói "mình hơn" (khác dataset). KHÔNG nói "họ gộp 1 box" — họ cũng multi-box (Figure 8).</a:t>
             </a:r>
           </a:p>
           <a:p>
@@ -4150,7 +4150,7 @@
                           </a:solidFill>
                           <a:latin typeface="Calibri"/>
                         </a:rPr>
-                        <a:t>, box gộp thô</a:t>
+                        <a:t> → không đo được model bịa box</a:t>
                       </a:r>
                     </a:p>
                   </a:txBody>
@@ -4172,7 +4172,7 @@
                           </a:solidFill>
                           <a:latin typeface="Calibri"/>
                         </a:rPr>
-                        <a:t>Đa lát + ca âm + multi-box</a:t>
+                        <a:t>Đa lát + ca âm</a:t>
                       </a:r>
                       <a:r>
                         <a:rPr sz="1150" b="0" i="0">
@@ -4181,7 +4181,7 @@
                           </a:solidFill>
                           <a:latin typeface="Calibri"/>
                         </a:rPr>
-                        <a:t> (tách từng ổ); split theo bệnh nhân</a:t>
+                        <a:t> (đo được false-positive); box khít từng ổ, split theo bệnh nhân</a:t>
                       </a:r>
                     </a:p>
                   </a:txBody>
@@ -5074,7 +5074,7 @@
                 </a:solidFill>
                 <a:latin typeface="Calibri"/>
               </a:rPr>
-              <a:t>Định vị ~0.27 ≈ </a:t>
+              <a:t>Định vị: cùng chuẩn (matched) mình </a:t>
             </a:r>
             <a:r>
               <a:rPr sz="1250" b="1" i="0">
@@ -5083,7 +5083,7 @@
                 </a:solidFill>
                 <a:latin typeface="Calibri"/>
               </a:rPr>
-              <a:t>cùng khoảng MedRegA (~0.23)</a:t>
+              <a:t>~0.32</a:t>
             </a:r>
             <a:r>
               <a:rPr sz="1250" b="0" i="0">
@@ -5092,7 +5092,25 @@
                 </a:solidFill>
                 <a:latin typeface="Calibri"/>
               </a:rPr>
-              <a:t> dù model nhỏ 5× — khác dataset, chỉ tham khảo.</a:t>
+              <a:t> vs MedRegA </a:t>
+            </a:r>
+            <a:r>
+              <a:rPr sz="1250" b="1" i="0">
+                <a:solidFill>
+                  <a:srgbClr val="1C2736"/>
+                </a:solidFill>
+                <a:latin typeface="Calibri"/>
+              </a:rPr>
+              <a:t>~0.23</a:t>
+            </a:r>
+            <a:r>
+              <a:rPr sz="1250" b="0" i="0">
+                <a:solidFill>
+                  <a:srgbClr val="1C2736"/>
+                </a:solidFill>
+                <a:latin typeface="Calibri"/>
+              </a:rPr>
+              <a:t>; pIoU CÓ PHẠT của mình 0.27 còn khắt khe hơn — đích họ lớn + box lỏng, khác dataset.</a:t>
             </a:r>
           </a:p>
         </p:txBody>

</xml_diff>